<commit_message>
zeroth presentation,literature review,approval form and reference paper
</commit_message>
<xml_diff>
--- a/AI-Powered Multimodal Misinformation Detection and Verification System.pptx
+++ b/AI-Powered Multimodal Misinformation Detection and Verification System.pptx
@@ -10,13 +10,14 @@
     <p:sldId id="258" r:id="rId4"/>
     <p:sldId id="259" r:id="rId5"/>
     <p:sldId id="260" r:id="rId6"/>
-    <p:sldId id="261" r:id="rId7"/>
-    <p:sldId id="262" r:id="rId8"/>
-    <p:sldId id="263" r:id="rId9"/>
-    <p:sldId id="264" r:id="rId10"/>
-    <p:sldId id="265" r:id="rId11"/>
-    <p:sldId id="266" r:id="rId12"/>
-    <p:sldId id="267" r:id="rId13"/>
+    <p:sldId id="268" r:id="rId7"/>
+    <p:sldId id="261" r:id="rId8"/>
+    <p:sldId id="262" r:id="rId9"/>
+    <p:sldId id="263" r:id="rId10"/>
+    <p:sldId id="264" r:id="rId11"/>
+    <p:sldId id="265" r:id="rId12"/>
+    <p:sldId id="266" r:id="rId13"/>
+    <p:sldId id="267" r:id="rId14"/>
   </p:sldIdLst>
   <p:sldSz cx="12192000" cy="6858000"/>
   <p:notesSz cx="6858000" cy="9144000"/>
@@ -125,6 +126,7 @@
             <p14:sldId id="258"/>
             <p14:sldId id="259"/>
             <p14:sldId id="260"/>
+            <p14:sldId id="268"/>
             <p14:sldId id="261"/>
             <p14:sldId id="262"/>
             <p14:sldId id="263"/>
@@ -5878,7 +5880,7 @@
         </p:nvSpPr>
         <p:spPr>
           <a:xfrm>
-            <a:off x="795130" y="1160863"/>
+            <a:off x="765633" y="639754"/>
             <a:ext cx="8876439" cy="1646302"/>
           </a:xfrm>
         </p:spPr>
@@ -6070,6 +6072,264 @@
 </file>
 
 <file path=ppt/slides/slide10.xml><?xml version="1.0" encoding="utf-8"?>
+<p:sld xmlns:a="http://schemas.openxmlformats.org/drawingml/2006/main" xmlns:r="http://schemas.openxmlformats.org/officeDocument/2006/relationships" xmlns:p="http://schemas.openxmlformats.org/presentationml/2006/main">
+  <p:cSld>
+    <p:spTree>
+      <p:nvGrpSpPr>
+        <p:cNvPr id="1" name="">
+          <a:extLst>
+            <a:ext uri="{FF2B5EF4-FFF2-40B4-BE49-F238E27FC236}">
+              <a16:creationId xmlns:a16="http://schemas.microsoft.com/office/drawing/2014/main" id="{B970787B-F54A-ADA6-29FB-FDF0D8F76D66}"/>
+            </a:ext>
+          </a:extLst>
+        </p:cNvPr>
+        <p:cNvGrpSpPr/>
+        <p:nvPr/>
+      </p:nvGrpSpPr>
+      <p:grpSpPr>
+        <a:xfrm>
+          <a:off x="0" y="0"/>
+          <a:ext cx="0" cy="0"/>
+          <a:chOff x="0" y="0"/>
+          <a:chExt cx="0" cy="0"/>
+        </a:xfrm>
+      </p:grpSpPr>
+      <p:sp>
+        <p:nvSpPr>
+          <p:cNvPr id="3" name="Subtitle 2">
+            <a:extLst>
+              <a:ext uri="{FF2B5EF4-FFF2-40B4-BE49-F238E27FC236}">
+                <a16:creationId xmlns:a16="http://schemas.microsoft.com/office/drawing/2014/main" id="{838C99A4-40FC-0B6B-E959-29CE96118373}"/>
+              </a:ext>
+            </a:extLst>
+          </p:cNvPr>
+          <p:cNvSpPr>
+            <a:spLocks noGrp="1"/>
+          </p:cNvSpPr>
+          <p:nvPr>
+            <p:ph type="subTitle" idx="1"/>
+          </p:nvPr>
+        </p:nvSpPr>
+        <p:spPr>
+          <a:xfrm>
+            <a:off x="766484" y="927944"/>
+            <a:ext cx="9203426" cy="5963867"/>
+          </a:xfrm>
+        </p:spPr>
+        <p:txBody>
+          <a:bodyPr>
+            <a:normAutofit/>
+          </a:bodyPr>
+          <a:lstStyle/>
+          <a:p>
+            <a:pPr marL="285750" indent="-285750" algn="l">
+              <a:buFont typeface="Arial" panose="020B0604020202020204" pitchFamily="34" charset="0"/>
+              <a:buChar char="•"/>
+            </a:pPr>
+            <a:r>
+              <a:rPr lang="en-IN" sz="1600" dirty="0">
+                <a:solidFill>
+                  <a:schemeClr val="tx1"/>
+                </a:solidFill>
+              </a:rPr>
+              <a:t>Intel Core i5 / AMD </a:t>
+            </a:r>
+            <a:r>
+              <a:rPr lang="en-IN" sz="1600" dirty="0" err="1">
+                <a:solidFill>
+                  <a:schemeClr val="tx1"/>
+                </a:solidFill>
+              </a:rPr>
+              <a:t>Ryzen</a:t>
+            </a:r>
+            <a:r>
+              <a:rPr lang="en-IN" sz="1600" dirty="0">
+                <a:solidFill>
+                  <a:schemeClr val="tx1"/>
+                </a:solidFill>
+              </a:rPr>
+              <a:t> 5+ </a:t>
+            </a:r>
+          </a:p>
+          <a:p>
+            <a:pPr marL="285750" indent="-285750" algn="l">
+              <a:buFont typeface="Arial" panose="020B0604020202020204" pitchFamily="34" charset="0"/>
+              <a:buChar char="•"/>
+            </a:pPr>
+            <a:r>
+              <a:rPr lang="en-IN" sz="1600" dirty="0">
+                <a:solidFill>
+                  <a:schemeClr val="tx1"/>
+                </a:solidFill>
+              </a:rPr>
+              <a:t>8 GB RAM (16 GB Recommended) </a:t>
+            </a:r>
+          </a:p>
+          <a:p>
+            <a:pPr marL="285750" indent="-285750" algn="l">
+              <a:buFont typeface="Arial" panose="020B0604020202020204" pitchFamily="34" charset="0"/>
+              <a:buChar char="•"/>
+            </a:pPr>
+            <a:r>
+              <a:rPr lang="en-IN" sz="1600" dirty="0">
+                <a:solidFill>
+                  <a:schemeClr val="tx1"/>
+                </a:solidFill>
+              </a:rPr>
+              <a:t>256 GB SSD (512 GB Recommended)</a:t>
+            </a:r>
+          </a:p>
+          <a:p>
+            <a:pPr marL="285750" indent="-285750" algn="l">
+              <a:buFont typeface="Arial" panose="020B0604020202020204" pitchFamily="34" charset="0"/>
+              <a:buChar char="•"/>
+            </a:pPr>
+            <a:r>
+              <a:rPr lang="en-IN" sz="1600" dirty="0">
+                <a:solidFill>
+                  <a:schemeClr val="tx1"/>
+                </a:solidFill>
+              </a:rPr>
+              <a:t> NVIDIA GPU (Optional) </a:t>
+            </a:r>
+          </a:p>
+          <a:p>
+            <a:pPr marL="285750" indent="-285750" algn="l">
+              <a:buFont typeface="Arial" panose="020B0604020202020204" pitchFamily="34" charset="0"/>
+              <a:buChar char="•"/>
+            </a:pPr>
+            <a:r>
+              <a:rPr lang="en-IN" sz="1600" dirty="0">
+                <a:solidFill>
+                  <a:schemeClr val="tx1"/>
+                </a:solidFill>
+              </a:rPr>
+              <a:t>Stable Internet Connection</a:t>
+            </a:r>
+          </a:p>
+        </p:txBody>
+      </p:sp>
+      <p:sp>
+        <p:nvSpPr>
+          <p:cNvPr id="5" name="Title 1">
+            <a:extLst>
+              <a:ext uri="{FF2B5EF4-FFF2-40B4-BE49-F238E27FC236}">
+                <a16:creationId xmlns:a16="http://schemas.microsoft.com/office/drawing/2014/main" id="{E94B8174-3B87-F513-41E9-1F0E0A50F01A}"/>
+              </a:ext>
+            </a:extLst>
+          </p:cNvPr>
+          <p:cNvSpPr txBox="1">
+            <a:spLocks/>
+          </p:cNvSpPr>
+          <p:nvPr/>
+        </p:nvSpPr>
+        <p:spPr>
+          <a:xfrm>
+            <a:off x="-1190136" y="216309"/>
+            <a:ext cx="7512278" cy="603480"/>
+          </a:xfrm>
+          <a:prstGeom prst="rect">
+            <a:avLst/>
+          </a:prstGeom>
+        </p:spPr>
+        <p:txBody>
+          <a:bodyPr vert="horz" lIns="91440" tIns="45720" rIns="91440" bIns="45720" rtlCol="0" anchor="b">
+            <a:noAutofit/>
+          </a:bodyPr>
+          <a:lstStyle>
+            <a:lvl1pPr algn="r" defTabSz="342900" rtl="0" eaLnBrk="1" latinLnBrk="0" hangingPunct="1">
+              <a:spcBef>
+                <a:spcPct val="0"/>
+              </a:spcBef>
+              <a:buNone/>
+              <a:defRPr sz="4050" kern="1200">
+                <a:solidFill>
+                  <a:schemeClr val="accent1"/>
+                </a:solidFill>
+                <a:latin typeface="+mj-lt"/>
+                <a:ea typeface="+mj-ea"/>
+                <a:cs typeface="+mj-cs"/>
+              </a:defRPr>
+            </a:lvl1pPr>
+            <a:lvl2pPr eaLnBrk="1" hangingPunct="1">
+              <a:defRPr>
+                <a:solidFill>
+                  <a:schemeClr val="tx2"/>
+                </a:solidFill>
+              </a:defRPr>
+            </a:lvl2pPr>
+            <a:lvl3pPr eaLnBrk="1" hangingPunct="1">
+              <a:defRPr>
+                <a:solidFill>
+                  <a:schemeClr val="tx2"/>
+                </a:solidFill>
+              </a:defRPr>
+            </a:lvl3pPr>
+            <a:lvl4pPr eaLnBrk="1" hangingPunct="1">
+              <a:defRPr>
+                <a:solidFill>
+                  <a:schemeClr val="tx2"/>
+                </a:solidFill>
+              </a:defRPr>
+            </a:lvl4pPr>
+            <a:lvl5pPr eaLnBrk="1" hangingPunct="1">
+              <a:defRPr>
+                <a:solidFill>
+                  <a:schemeClr val="tx2"/>
+                </a:solidFill>
+              </a:defRPr>
+            </a:lvl5pPr>
+            <a:lvl6pPr eaLnBrk="1" hangingPunct="1">
+              <a:defRPr>
+                <a:solidFill>
+                  <a:schemeClr val="tx2"/>
+                </a:solidFill>
+              </a:defRPr>
+            </a:lvl6pPr>
+            <a:lvl7pPr eaLnBrk="1" hangingPunct="1">
+              <a:defRPr>
+                <a:solidFill>
+                  <a:schemeClr val="tx2"/>
+                </a:solidFill>
+              </a:defRPr>
+            </a:lvl7pPr>
+            <a:lvl8pPr eaLnBrk="1" hangingPunct="1">
+              <a:defRPr>
+                <a:solidFill>
+                  <a:schemeClr val="tx2"/>
+                </a:solidFill>
+              </a:defRPr>
+            </a:lvl8pPr>
+            <a:lvl9pPr eaLnBrk="1" hangingPunct="1">
+              <a:defRPr>
+                <a:solidFill>
+                  <a:schemeClr val="tx2"/>
+                </a:solidFill>
+              </a:defRPr>
+            </a:lvl9pPr>
+          </a:lstStyle>
+          <a:p>
+            <a:r>
+              <a:rPr lang="en-IN" dirty="0"/>
+              <a:t>Hardware Requirements</a:t>
+            </a:r>
+          </a:p>
+        </p:txBody>
+      </p:sp>
+    </p:spTree>
+    <p:extLst>
+      <p:ext uri="{BB962C8B-B14F-4D97-AF65-F5344CB8AC3E}">
+        <p14:creationId xmlns:p14="http://schemas.microsoft.com/office/powerpoint/2010/main" val="1535770017"/>
+      </p:ext>
+    </p:extLst>
+  </p:cSld>
+  <p:clrMapOvr>
+    <a:masterClrMapping/>
+  </p:clrMapOvr>
+</p:sld>
+</file>
+
+<file path=ppt/slides/slide11.xml><?xml version="1.0" encoding="utf-8"?>
 <p:sld xmlns:a="http://schemas.openxmlformats.org/drawingml/2006/main" xmlns:r="http://schemas.openxmlformats.org/officeDocument/2006/relationships" xmlns:p="http://schemas.openxmlformats.org/presentationml/2006/main">
   <p:cSld>
     <p:spTree>
@@ -6265,7 +6525,7 @@
 </p:sld>
 </file>
 
-<file path=ppt/slides/slide11.xml><?xml version="1.0" encoding="utf-8"?>
+<file path=ppt/slides/slide12.xml><?xml version="1.0" encoding="utf-8"?>
 <p:sld xmlns:a="http://schemas.openxmlformats.org/drawingml/2006/main" xmlns:r="http://schemas.openxmlformats.org/officeDocument/2006/relationships" xmlns:p="http://schemas.openxmlformats.org/presentationml/2006/main">
   <p:cSld>
     <p:spTree>
@@ -6476,7 +6736,7 @@
 </p:sld>
 </file>
 
-<file path=ppt/slides/slide12.xml><?xml version="1.0" encoding="utf-8"?>
+<file path=ppt/slides/slide13.xml><?xml version="1.0" encoding="utf-8"?>
 <p:sld xmlns:a="http://schemas.openxmlformats.org/drawingml/2006/main" xmlns:r="http://schemas.openxmlformats.org/officeDocument/2006/relationships" xmlns:p="http://schemas.openxmlformats.org/presentationml/2006/main">
   <p:cSld>
     <p:spTree>
@@ -6673,7 +6933,7 @@
         <p:spPr>
           <a:xfrm>
             <a:off x="894303" y="1533778"/>
-            <a:ext cx="8943033" cy="4615813"/>
+            <a:ext cx="9093759" cy="5248859"/>
           </a:xfrm>
         </p:spPr>
         <p:txBody>
@@ -6682,36 +6942,74 @@
           </a:bodyPr>
           <a:lstStyle/>
           <a:p>
-            <a:pPr algn="l">
+            <a:pPr marL="342900" indent="-342900" algn="l">
               <a:lnSpc>
                 <a:spcPct val="150000"/>
               </a:lnSpc>
+              <a:buFont typeface="Wingdings" panose="05000000000000000000" pitchFamily="2" charset="2"/>
+              <a:buChar char="q"/>
             </a:pPr>
             <a:r>
-              <a:rPr lang="en-IN" sz="1600" dirty="0">
-                <a:solidFill>
-                  <a:schemeClr val="tx1"/>
-                </a:solidFill>
-              </a:rPr>
-              <a:t>The rapid spread of misinformation across digital platforms has become a major challenge, especially with the increasing use of AI-generated content and deepfake technology. Existing fake news detection systems primarily focus on a single type of media, making them less effective against multimodal misinformation.</a:t>
-            </a:r>
-          </a:p>
-          <a:p>
-            <a:pPr algn="l">
+              <a:rPr lang="en-US" sz="1600" dirty="0">
+                <a:solidFill>
+                  <a:schemeClr val="tx1"/>
+                </a:solidFill>
+              </a:rPr>
+              <a:t>Rapid growth of AI-generated content and deepfake technology has increased the spread of misinformation.</a:t>
+            </a:r>
+          </a:p>
+          <a:p>
+            <a:pPr marL="342900" indent="-342900" algn="l">
               <a:lnSpc>
                 <a:spcPct val="150000"/>
               </a:lnSpc>
+              <a:buFont typeface="Wingdings" panose="05000000000000000000" pitchFamily="2" charset="2"/>
+              <a:buChar char="q"/>
             </a:pPr>
             <a:r>
-              <a:rPr lang="en-IN" sz="1600" dirty="0">
-                <a:solidFill>
-                  <a:schemeClr val="tx1"/>
-                </a:solidFill>
-              </a:rPr>
-              <a:t>This project proposes an AI-powered web application capable of detecting misinformation in text, PDF documents, images, and videos. The system combines </a:t>
-            </a:r>
-            <a:r>
-              <a:rPr lang="en-IN" sz="1600" dirty="0" err="1">
+              <a:rPr lang="en-US" sz="1600" dirty="0">
+                <a:solidFill>
+                  <a:schemeClr val="tx1"/>
+                </a:solidFill>
+              </a:rPr>
+              <a:t>Existing fake news detection systems mainly focus on a single media type, limiting their effectiveness.</a:t>
+            </a:r>
+          </a:p>
+          <a:p>
+            <a:pPr marL="342900" indent="-342900" algn="l">
+              <a:lnSpc>
+                <a:spcPct val="150000"/>
+              </a:lnSpc>
+              <a:buFont typeface="Wingdings" panose="05000000000000000000" pitchFamily="2" charset="2"/>
+              <a:buChar char="q"/>
+            </a:pPr>
+            <a:r>
+              <a:rPr lang="en-US" sz="1600" dirty="0">
+                <a:solidFill>
+                  <a:schemeClr val="tx1"/>
+                </a:solidFill>
+              </a:rPr>
+              <a:t>Proposed an AI-powered web application to detect misinformation in text, PDF documents, images, and videos.</a:t>
+            </a:r>
+          </a:p>
+          <a:p>
+            <a:pPr marL="342900" indent="-342900" algn="l">
+              <a:lnSpc>
+                <a:spcPct val="150000"/>
+              </a:lnSpc>
+              <a:buFont typeface="Wingdings" panose="05000000000000000000" pitchFamily="2" charset="2"/>
+              <a:buChar char="q"/>
+            </a:pPr>
+            <a:r>
+              <a:rPr lang="en-US" sz="1600" dirty="0">
+                <a:solidFill>
+                  <a:schemeClr val="tx1"/>
+                </a:solidFill>
+              </a:rPr>
+              <a:t>Uses </a:t>
+            </a:r>
+            <a:r>
+              <a:rPr lang="en-US" sz="1600" dirty="0" err="1">
                 <a:solidFill>
                   <a:schemeClr val="tx1"/>
                 </a:solidFill>
@@ -6719,7 +7017,7 @@
               <a:t>DistilBERT</a:t>
             </a:r>
             <a:r>
-              <a:rPr lang="en-IN" sz="1600" dirty="0">
+              <a:rPr lang="en-US" sz="1600" dirty="0">
                 <a:solidFill>
                   <a:schemeClr val="tx1"/>
                 </a:solidFill>
@@ -6727,7 +7025,7 @@
               <a:t> for text analysis, </a:t>
             </a:r>
             <a:r>
-              <a:rPr lang="en-IN" sz="1600" dirty="0" err="1">
+              <a:rPr lang="en-US" sz="1600" dirty="0" err="1">
                 <a:solidFill>
                   <a:schemeClr val="tx1"/>
                 </a:solidFill>
@@ -6735,15 +7033,47 @@
               <a:t>EfficientNet</a:t>
             </a:r>
             <a:r>
-              <a:rPr lang="en-IN" sz="1600" dirty="0">
-                <a:solidFill>
-                  <a:schemeClr val="tx1"/>
-                </a:solidFill>
-              </a:rPr>
-              <a:t> for image analysis, and a video analysis model for video analysis. The outputs are fused using a Multilayer Perceptron (MLP), while SHAP Explainable AI provides transparent explanations for every prediction. The proposed system aims to deliver accurate, scalable, and explainable misinformation detection through a unified platform.</a:t>
-            </a:r>
-          </a:p>
-          <a:p>
+              <a:rPr lang="en-US" sz="1600" dirty="0">
+                <a:solidFill>
+                  <a:schemeClr val="tx1"/>
+                </a:solidFill>
+              </a:rPr>
+              <a:t> for image analysis, and a video analysis model for video analysis.</a:t>
+            </a:r>
+          </a:p>
+          <a:p>
+            <a:pPr marL="342900" indent="-342900" algn="l">
+              <a:lnSpc>
+                <a:spcPct val="150000"/>
+              </a:lnSpc>
+              <a:buFont typeface="Wingdings" panose="05000000000000000000" pitchFamily="2" charset="2"/>
+              <a:buChar char="q"/>
+            </a:pPr>
+            <a:r>
+              <a:rPr lang="en-US" sz="1600" dirty="0">
+                <a:solidFill>
+                  <a:schemeClr val="tx1"/>
+                </a:solidFill>
+              </a:rPr>
+              <a:t>Combines predictions using a Multilayer Perceptron (MLP) and provides transparent explanations through SHAP Explainable AI.</a:t>
+            </a:r>
+          </a:p>
+          <a:p>
+            <a:pPr marL="342900" indent="-342900" algn="l">
+              <a:lnSpc>
+                <a:spcPct val="150000"/>
+              </a:lnSpc>
+              <a:buFont typeface="Wingdings" panose="05000000000000000000" pitchFamily="2" charset="2"/>
+              <a:buChar char="q"/>
+            </a:pPr>
+            <a:r>
+              <a:rPr lang="en-US" sz="1600" dirty="0">
+                <a:solidFill>
+                  <a:schemeClr val="tx1"/>
+                </a:solidFill>
+              </a:rPr>
+              <a:t>Aims to provide accurate, scalable, and explainable multimodal misinformation detection through a unified platform.</a:t>
+            </a:r>
             <a:endParaRPr lang="en-IN" dirty="0"/>
           </a:p>
         </p:txBody>
@@ -6845,10 +7175,12 @@
           </a:bodyPr>
           <a:lstStyle/>
           <a:p>
-            <a:pPr algn="l">
+            <a:pPr marL="285750" indent="-285750" algn="l">
               <a:lnSpc>
                 <a:spcPct val="150000"/>
               </a:lnSpc>
+              <a:buFont typeface="Wingdings" panose="05000000000000000000" pitchFamily="2" charset="2"/>
+              <a:buChar char="Ø"/>
             </a:pPr>
             <a:r>
               <a:rPr lang="en-IN" sz="1600" dirty="0">
@@ -6856,14 +7188,16 @@
                   <a:schemeClr val="tx1"/>
                 </a:solidFill>
               </a:rPr>
-              <a:t>With the rapid growth of social media, misinformation spreads faster than ever before. The emergence of advanced AI technologies has enabled the creation of highly convincing fake text, manipulated images, and deepfake videos, making manual verification increasingly difficult.</a:t>
-            </a:r>
-          </a:p>
-          <a:p>
-            <a:pPr algn="l">
+              <a:t>Social media has accelerated the spread of misinformation across digital platforms.</a:t>
+            </a:r>
+          </a:p>
+          <a:p>
+            <a:pPr marL="285750" indent="-285750" algn="l">
               <a:lnSpc>
                 <a:spcPct val="150000"/>
               </a:lnSpc>
+              <a:buFont typeface="Wingdings" panose="05000000000000000000" pitchFamily="2" charset="2"/>
+              <a:buChar char="Ø"/>
             </a:pPr>
             <a:r>
               <a:rPr lang="en-IN" sz="1600" dirty="0">
@@ -6871,7 +7205,58 @@
                   <a:schemeClr val="tx1"/>
                 </a:solidFill>
               </a:rPr>
-              <a:t>Artificial Intelligence provides an effective solution by automatically analysing different forms of media and identifying misleading content. This project focuses on developing a multimodal misinformation detection system that combines Natural Language Processing and Computer Vision techniques to verify information from multiple sources within a single platform.</a:t>
+              <a:t>AI technologies have enabled the creation of convincing fake text, manipulated images, and deepfake videos.</a:t>
+            </a:r>
+          </a:p>
+          <a:p>
+            <a:pPr marL="285750" indent="-285750" algn="l">
+              <a:lnSpc>
+                <a:spcPct val="150000"/>
+              </a:lnSpc>
+              <a:buFont typeface="Wingdings" panose="05000000000000000000" pitchFamily="2" charset="2"/>
+              <a:buChar char="Ø"/>
+            </a:pPr>
+            <a:r>
+              <a:rPr lang="en-IN" sz="1600" dirty="0">
+                <a:solidFill>
+                  <a:schemeClr val="tx1"/>
+                </a:solidFill>
+              </a:rPr>
+              <a:t>Manual verification of such content is time-consuming and often unreliable.</a:t>
+            </a:r>
+          </a:p>
+          <a:p>
+            <a:pPr marL="285750" indent="-285750" algn="l">
+              <a:lnSpc>
+                <a:spcPct val="150000"/>
+              </a:lnSpc>
+              <a:buFont typeface="Wingdings" panose="05000000000000000000" pitchFamily="2" charset="2"/>
+              <a:buChar char="Ø"/>
+            </a:pPr>
+            <a:r>
+              <a:rPr lang="en-IN" sz="1600" dirty="0">
+                <a:solidFill>
+                  <a:schemeClr val="tx1"/>
+                </a:solidFill>
+              </a:rPr>
+              <a:t>Artificial Intelligence can automatically analyse multiple media types to identify misinformation.</a:t>
+            </a:r>
+          </a:p>
+          <a:p>
+            <a:pPr marL="285750" indent="-285750" algn="l">
+              <a:lnSpc>
+                <a:spcPct val="150000"/>
+              </a:lnSpc>
+              <a:buFont typeface="Wingdings" panose="05000000000000000000" pitchFamily="2" charset="2"/>
+              <a:buChar char="Ø"/>
+            </a:pPr>
+            <a:r>
+              <a:rPr lang="en-IN" sz="1600" dirty="0">
+                <a:solidFill>
+                  <a:schemeClr val="tx1"/>
+                </a:solidFill>
+              </a:rPr>
+              <a:t>The proposed system combines Natural Language Processing (NLP) and Computer Vision (CV) techniques to verify information from text, PDF documents, images, and videos within a single platform.</a:t>
             </a:r>
           </a:p>
           <a:p>
@@ -6991,12 +7376,12 @@
               </a:lnSpc>
             </a:pPr>
             <a:r>
-              <a:rPr lang="en-US" sz="1600" dirty="0">
-                <a:solidFill>
-                  <a:schemeClr val="tx1"/>
-                </a:solidFill>
-              </a:rPr>
-              <a:t>Develop an AI-powered multimodal system capable of detecting and verifying misinformation across text, PDF documents, images, and videos while providing explainable predictions through a single web-based platform.</a:t>
+              <a:rPr lang="en-IN" sz="1600" dirty="0">
+                <a:solidFill>
+                  <a:schemeClr val="tx1"/>
+                </a:solidFill>
+              </a:rPr>
+              <a:t>The rapid spread of misinformation across digital platforms has become a significant challenge due to the increasing use of AI-generated content, manipulated images, and deepfake videos. Existing misinformation detection systems often focus on a single media type, resulting in limited accuracy and a lack of comprehensive verification across multiple content formats. Furthermore, many existing solutions provide little or no explanation for their predictions, making it difficult for users to trust the results.</a:t>
             </a:r>
             <a:endParaRPr lang="en-IN" dirty="0">
               <a:solidFill>
@@ -7099,11 +7484,19 @@
         </p:spPr>
         <p:txBody>
           <a:bodyPr>
-            <a:normAutofit fontScale="92500" lnSpcReduction="10000"/>
+            <a:normAutofit/>
           </a:bodyPr>
           <a:lstStyle/>
           <a:p>
             <a:pPr algn="l"/>
+            <a:endParaRPr lang="en-IN" sz="1600" dirty="0">
+              <a:solidFill>
+                <a:schemeClr val="tx1"/>
+              </a:solidFill>
+            </a:endParaRPr>
+          </a:p>
+          <a:p>
+            <a:pPr algn="l"/>
             <a:r>
               <a:rPr lang="en-IN" sz="1600" dirty="0">
                 <a:solidFill>
@@ -7122,7 +7515,22 @@
             </a:r>
           </a:p>
           <a:p>
+            <a:pPr algn="l">
+              <a:lnSpc>
+                <a:spcPct val="150000"/>
+              </a:lnSpc>
+            </a:pPr>
+            <a:endParaRPr lang="en-IN" sz="1600" u="sng" dirty="0">
+              <a:solidFill>
+                <a:schemeClr val="tx1"/>
+              </a:solidFill>
+            </a:endParaRPr>
+          </a:p>
+          <a:p>
             <a:pPr marL="285750" indent="-285750" algn="l">
+              <a:lnSpc>
+                <a:spcPct val="150000"/>
+              </a:lnSpc>
               <a:buFont typeface="Arial" panose="020B0604020202020204" pitchFamily="34" charset="0"/>
               <a:buChar char="•"/>
             </a:pPr>
@@ -7137,6 +7545,9 @@
           </a:p>
           <a:p>
             <a:pPr marL="285750" indent="-285750" algn="l">
+              <a:lnSpc>
+                <a:spcPct val="150000"/>
+              </a:lnSpc>
               <a:buFont typeface="Arial" panose="020B0604020202020204" pitchFamily="34" charset="0"/>
               <a:buChar char="•"/>
             </a:pPr>
@@ -7161,53 +7572,6 @@
             </a:endParaRPr>
           </a:p>
           <a:p>
-            <a:pPr algn="l"/>
-            <a:r>
-              <a:rPr lang="en-IN" sz="1600" dirty="0">
-                <a:solidFill>
-                  <a:schemeClr val="tx1"/>
-                </a:solidFill>
-              </a:rPr>
-              <a:t>Paper 2: </a:t>
-            </a:r>
-            <a:r>
-              <a:rPr lang="en-IN" sz="1600" u="sng" dirty="0">
-                <a:solidFill>
-                  <a:schemeClr val="tx1"/>
-                </a:solidFill>
-              </a:rPr>
-              <a:t>A multi-level fusion-based framework for multimodal fake news classification using semantic feature extraction</a:t>
-            </a:r>
-          </a:p>
-          <a:p>
-            <a:pPr marL="285750" indent="-285750" algn="l">
-              <a:buFont typeface="Arial" panose="020B0604020202020204" pitchFamily="34" charset="0"/>
-              <a:buChar char="•"/>
-            </a:pPr>
-            <a:r>
-              <a:rPr lang="en-IN" sz="1600" dirty="0">
-                <a:solidFill>
-                  <a:schemeClr val="tx1"/>
-                </a:solidFill>
-              </a:rPr>
-              <a:t>Multimodal fake news detection using semantic feature extraction. </a:t>
-            </a:r>
-          </a:p>
-          <a:p>
-            <a:pPr marL="285750" indent="-285750" algn="l">
-              <a:buFont typeface="Arial" panose="020B0604020202020204" pitchFamily="34" charset="0"/>
-              <a:buChar char="•"/>
-            </a:pPr>
-            <a:r>
-              <a:rPr lang="en-IN" sz="1600" dirty="0">
-                <a:solidFill>
-                  <a:schemeClr val="tx1"/>
-                </a:solidFill>
-              </a:rPr>
-              <a:t>Supports text and image analysis. </a:t>
-            </a:r>
-          </a:p>
-          <a:p>
             <a:pPr marL="285750" indent="-285750" algn="l">
               <a:buFont typeface="Arial" panose="020B0604020202020204" pitchFamily="34" charset="0"/>
               <a:buChar char="•"/>
@@ -7226,7 +7590,7 @@
                   <a:schemeClr val="tx1"/>
                 </a:solidFill>
               </a:rPr>
-              <a:t>Paper 3: </a:t>
+              <a:t>Paper 2: </a:t>
             </a:r>
             <a:r>
               <a:rPr lang="en-IN" sz="1600" u="sng" dirty="0">
@@ -7234,11 +7598,26 @@
                   <a:schemeClr val="tx1"/>
                 </a:solidFill>
               </a:rPr>
-              <a:t>A fake news detection model using the integration of multimodal attention mechanism and residual convolutional network</a:t>
-            </a:r>
+              <a:t>A multi-level fusion-based framework for multimodal fake news classification using semantic feature extraction</a:t>
+            </a:r>
+          </a:p>
+          <a:p>
+            <a:pPr algn="l">
+              <a:lnSpc>
+                <a:spcPct val="150000"/>
+              </a:lnSpc>
+            </a:pPr>
+            <a:endParaRPr lang="en-IN" sz="1600" u="sng" dirty="0">
+              <a:solidFill>
+                <a:schemeClr val="tx1"/>
+              </a:solidFill>
+            </a:endParaRPr>
           </a:p>
           <a:p>
             <a:pPr marL="285750" indent="-285750" algn="l">
+              <a:lnSpc>
+                <a:spcPct val="150000"/>
+              </a:lnSpc>
               <a:buFont typeface="Arial" panose="020B0604020202020204" pitchFamily="34" charset="0"/>
               <a:buChar char="•"/>
             </a:pPr>
@@ -7248,11 +7627,14 @@
                   <a:schemeClr val="tx1"/>
                 </a:solidFill>
               </a:rPr>
-              <a:t>Multimodal attention mechanism with residual convolutional networks. </a:t>
+              <a:t>Multimodal fake news detection using semantic feature extraction. </a:t>
             </a:r>
           </a:p>
           <a:p>
             <a:pPr marL="285750" indent="-285750" algn="l">
+              <a:lnSpc>
+                <a:spcPct val="150000"/>
+              </a:lnSpc>
               <a:buFont typeface="Arial" panose="020B0604020202020204" pitchFamily="34" charset="0"/>
               <a:buChar char="•"/>
             </a:pPr>
@@ -7262,7 +7644,7 @@
                   <a:schemeClr val="tx1"/>
                 </a:solidFill>
               </a:rPr>
-              <a:t>Improves image-text classification accuracy. </a:t>
+              <a:t>Supports text and image analysis. </a:t>
             </a:r>
           </a:p>
           <a:p>
@@ -7278,70 +7660,11 @@
           </a:p>
           <a:p>
             <a:pPr algn="l"/>
-            <a:r>
-              <a:rPr lang="en-IN" sz="1600" u="sng" dirty="0">
-                <a:solidFill>
-                  <a:schemeClr val="tx1"/>
-                </a:solidFill>
-              </a:rPr>
-              <a:t>Limitations</a:t>
-            </a:r>
-          </a:p>
-          <a:p>
-            <a:pPr marL="285750" indent="-285750" algn="l">
-              <a:buFont typeface="Arial" panose="020B0604020202020204" pitchFamily="34" charset="0"/>
-              <a:buChar char="•"/>
-            </a:pPr>
-            <a:r>
-              <a:rPr lang="en-IN" sz="1600" dirty="0">
-                <a:solidFill>
-                  <a:schemeClr val="tx1"/>
-                </a:solidFill>
-              </a:rPr>
-              <a:t>Limited support for multiple media types. </a:t>
-            </a:r>
-          </a:p>
-          <a:p>
-            <a:pPr marL="285750" indent="-285750" algn="l">
-              <a:buFont typeface="Arial" panose="020B0604020202020204" pitchFamily="34" charset="0"/>
-              <a:buChar char="•"/>
-            </a:pPr>
-            <a:r>
-              <a:rPr lang="en-IN" sz="1600" dirty="0">
-                <a:solidFill>
-                  <a:schemeClr val="tx1"/>
-                </a:solidFill>
-              </a:rPr>
-              <a:t>No unified platform for text, PDF, image, and video verification. </a:t>
-            </a:r>
-          </a:p>
-          <a:p>
-            <a:pPr marL="285750" indent="-285750" algn="l">
-              <a:buFont typeface="Arial" panose="020B0604020202020204" pitchFamily="34" charset="0"/>
-              <a:buChar char="•"/>
-            </a:pPr>
-            <a:r>
-              <a:rPr lang="en-IN" sz="1600" dirty="0">
-                <a:solidFill>
-                  <a:schemeClr val="tx1"/>
-                </a:solidFill>
-              </a:rPr>
-              <a:t>Limited explainability of AI predictions. </a:t>
-            </a:r>
-          </a:p>
-          <a:p>
-            <a:pPr marL="285750" indent="-285750" algn="l">
-              <a:buFont typeface="Arial" panose="020B0604020202020204" pitchFamily="34" charset="0"/>
-              <a:buChar char="•"/>
-            </a:pPr>
-            <a:r>
-              <a:rPr lang="en-IN" sz="1600" dirty="0">
-                <a:solidFill>
-                  <a:schemeClr val="tx1"/>
-                </a:solidFill>
-              </a:rPr>
-              <a:t>Real-time verification remains a challenge.</a:t>
-            </a:r>
+            <a:endParaRPr lang="en-IN" sz="1600" dirty="0">
+              <a:solidFill>
+                <a:schemeClr val="tx1"/>
+              </a:solidFill>
+            </a:endParaRPr>
           </a:p>
         </p:txBody>
       </p:sp>
@@ -7359,6 +7682,230 @@
 </file>
 
 <file path=ppt/slides/slide6.xml><?xml version="1.0" encoding="utf-8"?>
+<p:sld xmlns:a="http://schemas.openxmlformats.org/drawingml/2006/main" xmlns:r="http://schemas.openxmlformats.org/officeDocument/2006/relationships" xmlns:p="http://schemas.openxmlformats.org/presentationml/2006/main">
+  <p:cSld>
+    <p:spTree>
+      <p:nvGrpSpPr>
+        <p:cNvPr id="1" name="">
+          <a:extLst>
+            <a:ext uri="{FF2B5EF4-FFF2-40B4-BE49-F238E27FC236}">
+              <a16:creationId xmlns:a16="http://schemas.microsoft.com/office/drawing/2014/main" id="{27D06B57-FECE-7174-A0F5-0913F2C6DFD6}"/>
+            </a:ext>
+          </a:extLst>
+        </p:cNvPr>
+        <p:cNvGrpSpPr/>
+        <p:nvPr/>
+      </p:nvGrpSpPr>
+      <p:grpSpPr>
+        <a:xfrm>
+          <a:off x="0" y="0"/>
+          <a:ext cx="0" cy="0"/>
+          <a:chOff x="0" y="0"/>
+          <a:chExt cx="0" cy="0"/>
+        </a:xfrm>
+      </p:grpSpPr>
+      <p:sp>
+        <p:nvSpPr>
+          <p:cNvPr id="3" name="Subtitle 2">
+            <a:extLst>
+              <a:ext uri="{FF2B5EF4-FFF2-40B4-BE49-F238E27FC236}">
+                <a16:creationId xmlns:a16="http://schemas.microsoft.com/office/drawing/2014/main" id="{FBD7B837-8577-46B2-B5FF-7E7C4319937C}"/>
+              </a:ext>
+            </a:extLst>
+          </p:cNvPr>
+          <p:cNvSpPr>
+            <a:spLocks noGrp="1"/>
+          </p:cNvSpPr>
+          <p:nvPr>
+            <p:ph type="subTitle" idx="1"/>
+          </p:nvPr>
+        </p:nvSpPr>
+        <p:spPr>
+          <a:xfrm>
+            <a:off x="736987" y="1046533"/>
+            <a:ext cx="9203426" cy="5963867"/>
+          </a:xfrm>
+        </p:spPr>
+        <p:txBody>
+          <a:bodyPr>
+            <a:normAutofit/>
+          </a:bodyPr>
+          <a:lstStyle/>
+          <a:p>
+            <a:pPr algn="l"/>
+            <a:endParaRPr lang="en-IN" sz="1600" dirty="0">
+              <a:solidFill>
+                <a:schemeClr val="tx1"/>
+              </a:solidFill>
+            </a:endParaRPr>
+          </a:p>
+          <a:p>
+            <a:pPr algn="l"/>
+            <a:r>
+              <a:rPr lang="en-IN" sz="1600" dirty="0">
+                <a:solidFill>
+                  <a:schemeClr val="tx1"/>
+                </a:solidFill>
+              </a:rPr>
+              <a:t>Paper 3: </a:t>
+            </a:r>
+            <a:r>
+              <a:rPr lang="en-IN" sz="1600" u="sng" dirty="0">
+                <a:solidFill>
+                  <a:schemeClr val="tx1"/>
+                </a:solidFill>
+              </a:rPr>
+              <a:t>A fake news detection model using the integration of multimodal attention mechanism and residual convolutional network</a:t>
+            </a:r>
+          </a:p>
+          <a:p>
+            <a:pPr algn="l"/>
+            <a:endParaRPr lang="en-IN" sz="1600" u="sng" dirty="0">
+              <a:solidFill>
+                <a:schemeClr val="tx1"/>
+              </a:solidFill>
+            </a:endParaRPr>
+          </a:p>
+          <a:p>
+            <a:pPr marL="285750" indent="-285750" algn="l">
+              <a:lnSpc>
+                <a:spcPct val="150000"/>
+              </a:lnSpc>
+              <a:buFont typeface="Arial" panose="020B0604020202020204" pitchFamily="34" charset="0"/>
+              <a:buChar char="•"/>
+            </a:pPr>
+            <a:r>
+              <a:rPr lang="en-IN" sz="1600" dirty="0">
+                <a:solidFill>
+                  <a:schemeClr val="tx1"/>
+                </a:solidFill>
+              </a:rPr>
+              <a:t>Multimodal attention mechanism with residual convolutional networks. </a:t>
+            </a:r>
+          </a:p>
+          <a:p>
+            <a:pPr marL="285750" indent="-285750" algn="l">
+              <a:lnSpc>
+                <a:spcPct val="150000"/>
+              </a:lnSpc>
+              <a:buFont typeface="Arial" panose="020B0604020202020204" pitchFamily="34" charset="0"/>
+              <a:buChar char="•"/>
+            </a:pPr>
+            <a:r>
+              <a:rPr lang="en-IN" sz="1600" dirty="0">
+                <a:solidFill>
+                  <a:schemeClr val="tx1"/>
+                </a:solidFill>
+              </a:rPr>
+              <a:t>Improves image-text classification accuracy. </a:t>
+            </a:r>
+          </a:p>
+          <a:p>
+            <a:pPr marL="285750" indent="-285750" algn="l">
+              <a:buFont typeface="Arial" panose="020B0604020202020204" pitchFamily="34" charset="0"/>
+              <a:buChar char="•"/>
+            </a:pPr>
+            <a:endParaRPr lang="en-IN" sz="1600" dirty="0">
+              <a:solidFill>
+                <a:schemeClr val="tx1"/>
+              </a:solidFill>
+            </a:endParaRPr>
+          </a:p>
+          <a:p>
+            <a:pPr algn="l"/>
+            <a:r>
+              <a:rPr lang="en-IN" sz="1800" u="sng" dirty="0">
+                <a:solidFill>
+                  <a:schemeClr val="tx1"/>
+                </a:solidFill>
+              </a:rPr>
+              <a:t>Limitations</a:t>
+            </a:r>
+          </a:p>
+          <a:p>
+            <a:pPr marL="285750" indent="-285750" algn="l">
+              <a:lnSpc>
+                <a:spcPct val="150000"/>
+              </a:lnSpc>
+              <a:buFont typeface="Arial" panose="020B0604020202020204" pitchFamily="34" charset="0"/>
+              <a:buChar char="•"/>
+            </a:pPr>
+            <a:r>
+              <a:rPr lang="en-IN" sz="1600" dirty="0">
+                <a:solidFill>
+                  <a:schemeClr val="tx1"/>
+                </a:solidFill>
+              </a:rPr>
+              <a:t>Limited support for multiple media types. </a:t>
+            </a:r>
+          </a:p>
+          <a:p>
+            <a:pPr marL="285750" indent="-285750" algn="l">
+              <a:lnSpc>
+                <a:spcPct val="150000"/>
+              </a:lnSpc>
+              <a:buFont typeface="Arial" panose="020B0604020202020204" pitchFamily="34" charset="0"/>
+              <a:buChar char="•"/>
+            </a:pPr>
+            <a:r>
+              <a:rPr lang="en-IN" sz="1600" dirty="0">
+                <a:solidFill>
+                  <a:schemeClr val="tx1"/>
+                </a:solidFill>
+              </a:rPr>
+              <a:t>No unified platform for text, PDF, image, and video verification. </a:t>
+            </a:r>
+          </a:p>
+          <a:p>
+            <a:pPr marL="285750" indent="-285750" algn="l">
+              <a:lnSpc>
+                <a:spcPct val="150000"/>
+              </a:lnSpc>
+              <a:buFont typeface="Arial" panose="020B0604020202020204" pitchFamily="34" charset="0"/>
+              <a:buChar char="•"/>
+            </a:pPr>
+            <a:r>
+              <a:rPr lang="en-IN" sz="1600" dirty="0">
+                <a:solidFill>
+                  <a:schemeClr val="tx1"/>
+                </a:solidFill>
+              </a:rPr>
+              <a:t>Limited explainability of AI predictions. </a:t>
+            </a:r>
+          </a:p>
+          <a:p>
+            <a:pPr marL="285750" indent="-285750" algn="l">
+              <a:lnSpc>
+                <a:spcPct val="150000"/>
+              </a:lnSpc>
+              <a:buFont typeface="Arial" panose="020B0604020202020204" pitchFamily="34" charset="0"/>
+              <a:buChar char="•"/>
+            </a:pPr>
+            <a:r>
+              <a:rPr lang="en-IN" sz="1600" dirty="0">
+                <a:solidFill>
+                  <a:schemeClr val="tx1"/>
+                </a:solidFill>
+              </a:rPr>
+              <a:t>Real-time verification remains a challenge.</a:t>
+            </a:r>
+          </a:p>
+        </p:txBody>
+      </p:sp>
+    </p:spTree>
+    <p:extLst>
+      <p:ext uri="{BB962C8B-B14F-4D97-AF65-F5344CB8AC3E}">
+        <p14:creationId xmlns:p14="http://schemas.microsoft.com/office/powerpoint/2010/main" val="3980559956"/>
+      </p:ext>
+    </p:extLst>
+  </p:cSld>
+  <p:clrMapOvr>
+    <a:masterClrMapping/>
+  </p:clrMapOvr>
+</p:sld>
+</file>
+
+<file path=ppt/slides/slide7.xml><?xml version="1.0" encoding="utf-8"?>
 <p:sld xmlns:a="http://schemas.openxmlformats.org/drawingml/2006/main" xmlns:r="http://schemas.openxmlformats.org/officeDocument/2006/relationships" xmlns:p="http://schemas.openxmlformats.org/presentationml/2006/main">
   <p:cSld>
     <p:spTree>
@@ -7512,7 +8059,7 @@
 </p:sld>
 </file>
 
-<file path=ppt/slides/slide7.xml><?xml version="1.0" encoding="utf-8"?>
+<file path=ppt/slides/slide8.xml><?xml version="1.0" encoding="utf-8"?>
 <p:sld xmlns:a="http://schemas.openxmlformats.org/drawingml/2006/main" xmlns:r="http://schemas.openxmlformats.org/officeDocument/2006/relationships" xmlns:p="http://schemas.openxmlformats.org/presentationml/2006/main">
   <p:cSld>
     <p:spTree>
@@ -7736,7 +8283,7 @@
 </p:sld>
 </file>
 
-<file path=ppt/slides/slide8.xml><?xml version="1.0" encoding="utf-8"?>
+<file path=ppt/slides/slide9.xml><?xml version="1.0" encoding="utf-8"?>
 <p:sld xmlns:a="http://schemas.openxmlformats.org/drawingml/2006/main" xmlns:r="http://schemas.openxmlformats.org/officeDocument/2006/relationships" xmlns:p="http://schemas.openxmlformats.org/presentationml/2006/main">
   <p:cSld>
     <p:spTree>
@@ -8104,264 +8651,6 @@
     <p:extLst>
       <p:ext uri="{BB962C8B-B14F-4D97-AF65-F5344CB8AC3E}">
         <p14:creationId xmlns:p14="http://schemas.microsoft.com/office/powerpoint/2010/main" val="3369277198"/>
-      </p:ext>
-    </p:extLst>
-  </p:cSld>
-  <p:clrMapOvr>
-    <a:masterClrMapping/>
-  </p:clrMapOvr>
-</p:sld>
-</file>
-
-<file path=ppt/slides/slide9.xml><?xml version="1.0" encoding="utf-8"?>
-<p:sld xmlns:a="http://schemas.openxmlformats.org/drawingml/2006/main" xmlns:r="http://schemas.openxmlformats.org/officeDocument/2006/relationships" xmlns:p="http://schemas.openxmlformats.org/presentationml/2006/main">
-  <p:cSld>
-    <p:spTree>
-      <p:nvGrpSpPr>
-        <p:cNvPr id="1" name="">
-          <a:extLst>
-            <a:ext uri="{FF2B5EF4-FFF2-40B4-BE49-F238E27FC236}">
-              <a16:creationId xmlns:a16="http://schemas.microsoft.com/office/drawing/2014/main" id="{B970787B-F54A-ADA6-29FB-FDF0D8F76D66}"/>
-            </a:ext>
-          </a:extLst>
-        </p:cNvPr>
-        <p:cNvGrpSpPr/>
-        <p:nvPr/>
-      </p:nvGrpSpPr>
-      <p:grpSpPr>
-        <a:xfrm>
-          <a:off x="0" y="0"/>
-          <a:ext cx="0" cy="0"/>
-          <a:chOff x="0" y="0"/>
-          <a:chExt cx="0" cy="0"/>
-        </a:xfrm>
-      </p:grpSpPr>
-      <p:sp>
-        <p:nvSpPr>
-          <p:cNvPr id="3" name="Subtitle 2">
-            <a:extLst>
-              <a:ext uri="{FF2B5EF4-FFF2-40B4-BE49-F238E27FC236}">
-                <a16:creationId xmlns:a16="http://schemas.microsoft.com/office/drawing/2014/main" id="{838C99A4-40FC-0B6B-E959-29CE96118373}"/>
-              </a:ext>
-            </a:extLst>
-          </p:cNvPr>
-          <p:cNvSpPr>
-            <a:spLocks noGrp="1"/>
-          </p:cNvSpPr>
-          <p:nvPr>
-            <p:ph type="subTitle" idx="1"/>
-          </p:nvPr>
-        </p:nvSpPr>
-        <p:spPr>
-          <a:xfrm>
-            <a:off x="766484" y="927944"/>
-            <a:ext cx="9203426" cy="5963867"/>
-          </a:xfrm>
-        </p:spPr>
-        <p:txBody>
-          <a:bodyPr>
-            <a:normAutofit/>
-          </a:bodyPr>
-          <a:lstStyle/>
-          <a:p>
-            <a:pPr marL="285750" indent="-285750" algn="l">
-              <a:buFont typeface="Arial" panose="020B0604020202020204" pitchFamily="34" charset="0"/>
-              <a:buChar char="•"/>
-            </a:pPr>
-            <a:r>
-              <a:rPr lang="en-IN" sz="1600" dirty="0">
-                <a:solidFill>
-                  <a:schemeClr val="tx1"/>
-                </a:solidFill>
-              </a:rPr>
-              <a:t>Intel Core i5 / AMD </a:t>
-            </a:r>
-            <a:r>
-              <a:rPr lang="en-IN" sz="1600" dirty="0" err="1">
-                <a:solidFill>
-                  <a:schemeClr val="tx1"/>
-                </a:solidFill>
-              </a:rPr>
-              <a:t>Ryzen</a:t>
-            </a:r>
-            <a:r>
-              <a:rPr lang="en-IN" sz="1600" dirty="0">
-                <a:solidFill>
-                  <a:schemeClr val="tx1"/>
-                </a:solidFill>
-              </a:rPr>
-              <a:t> 5+ </a:t>
-            </a:r>
-          </a:p>
-          <a:p>
-            <a:pPr marL="285750" indent="-285750" algn="l">
-              <a:buFont typeface="Arial" panose="020B0604020202020204" pitchFamily="34" charset="0"/>
-              <a:buChar char="•"/>
-            </a:pPr>
-            <a:r>
-              <a:rPr lang="en-IN" sz="1600" dirty="0">
-                <a:solidFill>
-                  <a:schemeClr val="tx1"/>
-                </a:solidFill>
-              </a:rPr>
-              <a:t>8 GB RAM (16 GB Recommended) </a:t>
-            </a:r>
-          </a:p>
-          <a:p>
-            <a:pPr marL="285750" indent="-285750" algn="l">
-              <a:buFont typeface="Arial" panose="020B0604020202020204" pitchFamily="34" charset="0"/>
-              <a:buChar char="•"/>
-            </a:pPr>
-            <a:r>
-              <a:rPr lang="en-IN" sz="1600" dirty="0">
-                <a:solidFill>
-                  <a:schemeClr val="tx1"/>
-                </a:solidFill>
-              </a:rPr>
-              <a:t>256 GB SSD (512 GB Recommended)</a:t>
-            </a:r>
-          </a:p>
-          <a:p>
-            <a:pPr marL="285750" indent="-285750" algn="l">
-              <a:buFont typeface="Arial" panose="020B0604020202020204" pitchFamily="34" charset="0"/>
-              <a:buChar char="•"/>
-            </a:pPr>
-            <a:r>
-              <a:rPr lang="en-IN" sz="1600" dirty="0">
-                <a:solidFill>
-                  <a:schemeClr val="tx1"/>
-                </a:solidFill>
-              </a:rPr>
-              <a:t> NVIDIA GPU (Optional) </a:t>
-            </a:r>
-          </a:p>
-          <a:p>
-            <a:pPr marL="285750" indent="-285750" algn="l">
-              <a:buFont typeface="Arial" panose="020B0604020202020204" pitchFamily="34" charset="0"/>
-              <a:buChar char="•"/>
-            </a:pPr>
-            <a:r>
-              <a:rPr lang="en-IN" sz="1600" dirty="0">
-                <a:solidFill>
-                  <a:schemeClr val="tx1"/>
-                </a:solidFill>
-              </a:rPr>
-              <a:t>Stable Internet Connection</a:t>
-            </a:r>
-          </a:p>
-        </p:txBody>
-      </p:sp>
-      <p:sp>
-        <p:nvSpPr>
-          <p:cNvPr id="5" name="Title 1">
-            <a:extLst>
-              <a:ext uri="{FF2B5EF4-FFF2-40B4-BE49-F238E27FC236}">
-                <a16:creationId xmlns:a16="http://schemas.microsoft.com/office/drawing/2014/main" id="{E94B8174-3B87-F513-41E9-1F0E0A50F01A}"/>
-              </a:ext>
-            </a:extLst>
-          </p:cNvPr>
-          <p:cNvSpPr txBox="1">
-            <a:spLocks/>
-          </p:cNvSpPr>
-          <p:nvPr/>
-        </p:nvSpPr>
-        <p:spPr>
-          <a:xfrm>
-            <a:off x="-1190136" y="216309"/>
-            <a:ext cx="7512278" cy="603480"/>
-          </a:xfrm>
-          <a:prstGeom prst="rect">
-            <a:avLst/>
-          </a:prstGeom>
-        </p:spPr>
-        <p:txBody>
-          <a:bodyPr vert="horz" lIns="91440" tIns="45720" rIns="91440" bIns="45720" rtlCol="0" anchor="b">
-            <a:noAutofit/>
-          </a:bodyPr>
-          <a:lstStyle>
-            <a:lvl1pPr algn="r" defTabSz="342900" rtl="0" eaLnBrk="1" latinLnBrk="0" hangingPunct="1">
-              <a:spcBef>
-                <a:spcPct val="0"/>
-              </a:spcBef>
-              <a:buNone/>
-              <a:defRPr sz="4050" kern="1200">
-                <a:solidFill>
-                  <a:schemeClr val="accent1"/>
-                </a:solidFill>
-                <a:latin typeface="+mj-lt"/>
-                <a:ea typeface="+mj-ea"/>
-                <a:cs typeface="+mj-cs"/>
-              </a:defRPr>
-            </a:lvl1pPr>
-            <a:lvl2pPr eaLnBrk="1" hangingPunct="1">
-              <a:defRPr>
-                <a:solidFill>
-                  <a:schemeClr val="tx2"/>
-                </a:solidFill>
-              </a:defRPr>
-            </a:lvl2pPr>
-            <a:lvl3pPr eaLnBrk="1" hangingPunct="1">
-              <a:defRPr>
-                <a:solidFill>
-                  <a:schemeClr val="tx2"/>
-                </a:solidFill>
-              </a:defRPr>
-            </a:lvl3pPr>
-            <a:lvl4pPr eaLnBrk="1" hangingPunct="1">
-              <a:defRPr>
-                <a:solidFill>
-                  <a:schemeClr val="tx2"/>
-                </a:solidFill>
-              </a:defRPr>
-            </a:lvl4pPr>
-            <a:lvl5pPr eaLnBrk="1" hangingPunct="1">
-              <a:defRPr>
-                <a:solidFill>
-                  <a:schemeClr val="tx2"/>
-                </a:solidFill>
-              </a:defRPr>
-            </a:lvl5pPr>
-            <a:lvl6pPr eaLnBrk="1" hangingPunct="1">
-              <a:defRPr>
-                <a:solidFill>
-                  <a:schemeClr val="tx2"/>
-                </a:solidFill>
-              </a:defRPr>
-            </a:lvl6pPr>
-            <a:lvl7pPr eaLnBrk="1" hangingPunct="1">
-              <a:defRPr>
-                <a:solidFill>
-                  <a:schemeClr val="tx2"/>
-                </a:solidFill>
-              </a:defRPr>
-            </a:lvl7pPr>
-            <a:lvl8pPr eaLnBrk="1" hangingPunct="1">
-              <a:defRPr>
-                <a:solidFill>
-                  <a:schemeClr val="tx2"/>
-                </a:solidFill>
-              </a:defRPr>
-            </a:lvl8pPr>
-            <a:lvl9pPr eaLnBrk="1" hangingPunct="1">
-              <a:defRPr>
-                <a:solidFill>
-                  <a:schemeClr val="tx2"/>
-                </a:solidFill>
-              </a:defRPr>
-            </a:lvl9pPr>
-          </a:lstStyle>
-          <a:p>
-            <a:r>
-              <a:rPr lang="en-IN" dirty="0"/>
-              <a:t>Hardware Requirements</a:t>
-            </a:r>
-          </a:p>
-        </p:txBody>
-      </p:sp>
-    </p:spTree>
-    <p:extLst>
-      <p:ext uri="{BB962C8B-B14F-4D97-AF65-F5344CB8AC3E}">
-        <p14:creationId xmlns:p14="http://schemas.microsoft.com/office/powerpoint/2010/main" val="1535770017"/>
       </p:ext>
     </p:extLst>
   </p:cSld>

</xml_diff>